<commit_message>
rapor+sunum: PPO ve SAC karsilastirma tablosu eklendi
5 tohum ortalamasi (ayni ortam/seed/protokol): PPO dort kalite olcutunde de onde
(eval getiri 458.5 vs 321.0, basari 0.96 vs 0.27, kapsama %96.7 vs %92.6,
carpisma 0.04 vs 0.07); bedeli PPO 1.5M vs SAC 500k adim (on-policy vs off-policy
ornek verimliligi). SAC degerleri algo/td3 teslimindeki sonuclar.csv'den.

Co-Authored-By: Claude Opus 4.8 (1M context) <noreply@anthropic.com>
</commit_message>
<xml_diff>
--- a/deliverables/sunum/220202046_sunum.pptx
+++ b/deliverables/sunum/220202046_sunum.pptx
@@ -18,6 +18,7 @@
     <p:sldId id="266" r:id="rId17"/>
     <p:sldId id="267" r:id="rId18"/>
     <p:sldId id="268" r:id="rId19"/>
+    <p:sldId id="269" r:id="rId20"/>
   </p:sldIdLst>
   <p:sldSz cx="12191695" cy="6858000" type="screen4x3"/>
   <p:notesSz cx="6858000" cy="9144000"/>
@@ -3549,6 +3550,588 @@
                   <a:srgbClr val="1A237E"/>
                 </a:solidFill>
               </a:rPr>
+              <a:t>PPO vs SAC Karsilastirmasi (ayni ortam/seed/protokol)</a:t>
+            </a:r>
+          </a:p>
+        </p:txBody>
+      </p:sp>
+      <p:graphicFrame>
+        <p:nvGraphicFramePr>
+          <p:cNvPr id="3" name="Table 2"/>
+          <p:cNvGraphicFramePr>
+            <a:graphicFrameLocks noGrp="1"/>
+          </p:cNvGraphicFramePr>
+          <p:nvPr/>
+        </p:nvGraphicFramePr>
+        <p:xfrm>
+          <a:off x="1097280" y="1371600"/>
+          <a:ext cx="9966960" cy="4206240"/>
+        </p:xfrm>
+        <a:graphic>
+          <a:graphicData uri="http://schemas.openxmlformats.org/drawingml/2006/table">
+            <a:tbl>
+              <a:tblPr firstRow="1" bandRow="1">
+                <a:tableStyleId>{5C22544A-7EE6-4342-B048-85BDC9FD1C3A}</a:tableStyleId>
+              </a:tblPr>
+              <a:tblGrid>
+                <a:gridCol w="4114800"/>
+                <a:gridCol w="2926080"/>
+                <a:gridCol w="2926080"/>
+              </a:tblGrid>
+              <a:tr h="525780">
+                <a:tc>
+                  <a:txBody>
+                    <a:bodyPr/>
+                    <a:lstStyle/>
+                    <a:p>
+                      <a:r>
+                        <a:rPr sz="1500" b="1">
+                          <a:solidFill>
+                            <a:srgbClr val="FFFFFF"/>
+                          </a:solidFill>
+                        </a:rPr>
+                        <a:t>Olcut</a:t>
+                      </a:r>
+                    </a:p>
+                  </a:txBody>
+                  <a:tcPr>
+                    <a:solidFill>
+                      <a:srgbClr val="1A237E"/>
+                    </a:solidFill>
+                  </a:tcPr>
+                </a:tc>
+                <a:tc>
+                  <a:txBody>
+                    <a:bodyPr/>
+                    <a:lstStyle/>
+                    <a:p>
+                      <a:r>
+                        <a:rPr sz="1500" b="1">
+                          <a:solidFill>
+                            <a:srgbClr val="FFFFFF"/>
+                          </a:solidFill>
+                        </a:rPr>
+                        <a:t>PPO (bu calisma)</a:t>
+                      </a:r>
+                    </a:p>
+                  </a:txBody>
+                  <a:tcPr>
+                    <a:solidFill>
+                      <a:srgbClr val="1A237E"/>
+                    </a:solidFill>
+                  </a:tcPr>
+                </a:tc>
+                <a:tc>
+                  <a:txBody>
+                    <a:bodyPr/>
+                    <a:lstStyle/>
+                    <a:p>
+                      <a:r>
+                        <a:rPr sz="1500" b="1">
+                          <a:solidFill>
+                            <a:srgbClr val="FFFFFF"/>
+                          </a:solidFill>
+                        </a:rPr>
+                        <a:t>SAC (algo/td3)</a:t>
+                      </a:r>
+                    </a:p>
+                  </a:txBody>
+                  <a:tcPr>
+                    <a:solidFill>
+                      <a:srgbClr val="1A237E"/>
+                    </a:solidFill>
+                  </a:tcPr>
+                </a:tc>
+              </a:tr>
+              <a:tr h="525780">
+                <a:tc>
+                  <a:txBody>
+                    <a:bodyPr/>
+                    <a:lstStyle/>
+                    <a:p>
+                      <a:r>
+                        <a:rPr sz="1400" b="0"/>
+                        <a:t>Aile</a:t>
+                      </a:r>
+                    </a:p>
+                  </a:txBody>
+                  <a:tcPr>
+                    <a:solidFill>
+                      <a:srgbClr val="F2F4FB"/>
+                    </a:solidFill>
+                  </a:tcPr>
+                </a:tc>
+                <a:tc>
+                  <a:txBody>
+                    <a:bodyPr/>
+                    <a:lstStyle/>
+                    <a:p>
+                      <a:r>
+                        <a:rPr sz="1400" b="1"/>
+                        <a:t>on-policy</a:t>
+                      </a:r>
+                    </a:p>
+                  </a:txBody>
+                  <a:tcPr>
+                    <a:solidFill>
+                      <a:srgbClr val="F2F4FB"/>
+                    </a:solidFill>
+                  </a:tcPr>
+                </a:tc>
+                <a:tc>
+                  <a:txBody>
+                    <a:bodyPr/>
+                    <a:lstStyle/>
+                    <a:p>
+                      <a:r>
+                        <a:rPr sz="1400" b="0"/>
+                        <a:t>off-policy</a:t>
+                      </a:r>
+                    </a:p>
+                  </a:txBody>
+                  <a:tcPr>
+                    <a:solidFill>
+                      <a:srgbClr val="F2F4FB"/>
+                    </a:solidFill>
+                  </a:tcPr>
+                </a:tc>
+              </a:tr>
+              <a:tr h="525780">
+                <a:tc>
+                  <a:txBody>
+                    <a:bodyPr/>
+                    <a:lstStyle/>
+                    <a:p>
+                      <a:r>
+                        <a:rPr sz="1400" b="0"/>
+                        <a:t>Replay buffer</a:t>
+                      </a:r>
+                    </a:p>
+                  </a:txBody>
+                  <a:tcPr>
+                    <a:solidFill>
+                      <a:srgbClr val="F2F4FB"/>
+                    </a:solidFill>
+                  </a:tcPr>
+                </a:tc>
+                <a:tc>
+                  <a:txBody>
+                    <a:bodyPr/>
+                    <a:lstStyle/>
+                    <a:p>
+                      <a:r>
+                        <a:rPr sz="1400" b="1"/>
+                        <a:t>yok</a:t>
+                      </a:r>
+                    </a:p>
+                  </a:txBody>
+                  <a:tcPr>
+                    <a:solidFill>
+                      <a:srgbClr val="F2F4FB"/>
+                    </a:solidFill>
+                  </a:tcPr>
+                </a:tc>
+                <a:tc>
+                  <a:txBody>
+                    <a:bodyPr/>
+                    <a:lstStyle/>
+                    <a:p>
+                      <a:r>
+                        <a:rPr sz="1400" b="0"/>
+                        <a:t>var</a:t>
+                      </a:r>
+                    </a:p>
+                  </a:txBody>
+                  <a:tcPr>
+                    <a:solidFill>
+                      <a:srgbClr val="F2F4FB"/>
+                    </a:solidFill>
+                  </a:tcPr>
+                </a:tc>
+              </a:tr>
+              <a:tr h="525780">
+                <a:tc>
+                  <a:txBody>
+                    <a:bodyPr/>
+                    <a:lstStyle/>
+                    <a:p>
+                      <a:r>
+                        <a:rPr sz="1400" b="0"/>
+                        <a:t>Egitim adimi</a:t>
+                      </a:r>
+                    </a:p>
+                  </a:txBody>
+                  <a:tcPr>
+                    <a:solidFill>
+                      <a:srgbClr val="F2F4FB"/>
+                    </a:solidFill>
+                  </a:tcPr>
+                </a:tc>
+                <a:tc>
+                  <a:txBody>
+                    <a:bodyPr/>
+                    <a:lstStyle/>
+                    <a:p>
+                      <a:r>
+                        <a:rPr sz="1400" b="1"/>
+                        <a:t>1.5M</a:t>
+                      </a:r>
+                    </a:p>
+                  </a:txBody>
+                  <a:tcPr>
+                    <a:solidFill>
+                      <a:srgbClr val="F2F4FB"/>
+                    </a:solidFill>
+                  </a:tcPr>
+                </a:tc>
+                <a:tc>
+                  <a:txBody>
+                    <a:bodyPr/>
+                    <a:lstStyle/>
+                    <a:p>
+                      <a:r>
+                        <a:rPr sz="1400" b="0"/>
+                        <a:t>500k</a:t>
+                      </a:r>
+                    </a:p>
+                  </a:txBody>
+                  <a:tcPr>
+                    <a:solidFill>
+                      <a:srgbClr val="F2F4FB"/>
+                    </a:solidFill>
+                  </a:tcPr>
+                </a:tc>
+              </a:tr>
+              <a:tr h="525780">
+                <a:tc>
+                  <a:txBody>
+                    <a:bodyPr/>
+                    <a:lstStyle/>
+                    <a:p>
+                      <a:r>
+                        <a:rPr sz="1400" b="0"/>
+                        <a:t>Ort. eval getirisi</a:t>
+                      </a:r>
+                    </a:p>
+                  </a:txBody>
+                  <a:tcPr>
+                    <a:solidFill>
+                      <a:srgbClr val="F2F4FB"/>
+                    </a:solidFill>
+                  </a:tcPr>
+                </a:tc>
+                <a:tc>
+                  <a:txBody>
+                    <a:bodyPr/>
+                    <a:lstStyle/>
+                    <a:p>
+                      <a:r>
+                        <a:rPr sz="1400" b="1"/>
+                        <a:t>458.5</a:t>
+                      </a:r>
+                    </a:p>
+                  </a:txBody>
+                  <a:tcPr>
+                    <a:solidFill>
+                      <a:srgbClr val="F2F4FB"/>
+                    </a:solidFill>
+                  </a:tcPr>
+                </a:tc>
+                <a:tc>
+                  <a:txBody>
+                    <a:bodyPr/>
+                    <a:lstStyle/>
+                    <a:p>
+                      <a:r>
+                        <a:rPr sz="1400" b="0"/>
+                        <a:t>321.0</a:t>
+                      </a:r>
+                    </a:p>
+                  </a:txBody>
+                  <a:tcPr>
+                    <a:solidFill>
+                      <a:srgbClr val="F2F4FB"/>
+                    </a:solidFill>
+                  </a:tcPr>
+                </a:tc>
+              </a:tr>
+              <a:tr h="525780">
+                <a:tc>
+                  <a:txBody>
+                    <a:bodyPr/>
+                    <a:lstStyle/>
+                    <a:p>
+                      <a:r>
+                        <a:rPr sz="1400" b="0"/>
+                        <a:t>Basari orani (6 oda)</a:t>
+                      </a:r>
+                    </a:p>
+                  </a:txBody>
+                  <a:tcPr>
+                    <a:solidFill>
+                      <a:srgbClr val="F2F4FB"/>
+                    </a:solidFill>
+                  </a:tcPr>
+                </a:tc>
+                <a:tc>
+                  <a:txBody>
+                    <a:bodyPr/>
+                    <a:lstStyle/>
+                    <a:p>
+                      <a:r>
+                        <a:rPr sz="1400" b="1"/>
+                        <a:t>0.96</a:t>
+                      </a:r>
+                    </a:p>
+                  </a:txBody>
+                  <a:tcPr>
+                    <a:solidFill>
+                      <a:srgbClr val="F2F4FB"/>
+                    </a:solidFill>
+                  </a:tcPr>
+                </a:tc>
+                <a:tc>
+                  <a:txBody>
+                    <a:bodyPr/>
+                    <a:lstStyle/>
+                    <a:p>
+                      <a:r>
+                        <a:rPr sz="1400" b="0"/>
+                        <a:t>0.27</a:t>
+                      </a:r>
+                    </a:p>
+                  </a:txBody>
+                  <a:tcPr>
+                    <a:solidFill>
+                      <a:srgbClr val="F2F4FB"/>
+                    </a:solidFill>
+                  </a:tcPr>
+                </a:tc>
+              </a:tr>
+              <a:tr h="525780">
+                <a:tc>
+                  <a:txBody>
+                    <a:bodyPr/>
+                    <a:lstStyle/>
+                    <a:p>
+                      <a:r>
+                        <a:rPr sz="1400" b="0"/>
+                        <a:t>Ort. kapsama %</a:t>
+                      </a:r>
+                    </a:p>
+                  </a:txBody>
+                  <a:tcPr>
+                    <a:solidFill>
+                      <a:srgbClr val="F2F4FB"/>
+                    </a:solidFill>
+                  </a:tcPr>
+                </a:tc>
+                <a:tc>
+                  <a:txBody>
+                    <a:bodyPr/>
+                    <a:lstStyle/>
+                    <a:p>
+                      <a:r>
+                        <a:rPr sz="1400" b="1"/>
+                        <a:t>96.7</a:t>
+                      </a:r>
+                    </a:p>
+                  </a:txBody>
+                  <a:tcPr>
+                    <a:solidFill>
+                      <a:srgbClr val="F2F4FB"/>
+                    </a:solidFill>
+                  </a:tcPr>
+                </a:tc>
+                <a:tc>
+                  <a:txBody>
+                    <a:bodyPr/>
+                    <a:lstStyle/>
+                    <a:p>
+                      <a:r>
+                        <a:rPr sz="1400" b="0"/>
+                        <a:t>92.6</a:t>
+                      </a:r>
+                    </a:p>
+                  </a:txBody>
+                  <a:tcPr>
+                    <a:solidFill>
+                      <a:srgbClr val="F2F4FB"/>
+                    </a:solidFill>
+                  </a:tcPr>
+                </a:tc>
+              </a:tr>
+              <a:tr h="525780">
+                <a:tc>
+                  <a:txBody>
+                    <a:bodyPr/>
+                    <a:lstStyle/>
+                    <a:p>
+                      <a:r>
+                        <a:rPr sz="1400" b="0"/>
+                        <a:t>Eval carpisma orani</a:t>
+                      </a:r>
+                    </a:p>
+                  </a:txBody>
+                  <a:tcPr>
+                    <a:solidFill>
+                      <a:srgbClr val="F2F4FB"/>
+                    </a:solidFill>
+                  </a:tcPr>
+                </a:tc>
+                <a:tc>
+                  <a:txBody>
+                    <a:bodyPr/>
+                    <a:lstStyle/>
+                    <a:p>
+                      <a:r>
+                        <a:rPr sz="1400" b="1"/>
+                        <a:t>0.04</a:t>
+                      </a:r>
+                    </a:p>
+                  </a:txBody>
+                  <a:tcPr>
+                    <a:solidFill>
+                      <a:srgbClr val="F2F4FB"/>
+                    </a:solidFill>
+                  </a:tcPr>
+                </a:tc>
+                <a:tc>
+                  <a:txBody>
+                    <a:bodyPr/>
+                    <a:lstStyle/>
+                    <a:p>
+                      <a:r>
+                        <a:rPr sz="1400" b="0"/>
+                        <a:t>0.07</a:t>
+                      </a:r>
+                    </a:p>
+                  </a:txBody>
+                  <a:tcPr>
+                    <a:solidFill>
+                      <a:srgbClr val="F2F4FB"/>
+                    </a:solidFill>
+                  </a:tcPr>
+                </a:tc>
+              </a:tr>
+            </a:tbl>
+          </a:graphicData>
+        </a:graphic>
+      </p:graphicFrame>
+      <p:sp>
+        <p:nvSpPr>
+          <p:cNvPr id="4" name="TextBox 3"/>
+          <p:cNvSpPr txBox="1"/>
+          <p:nvPr/>
+        </p:nvSpPr>
+        <p:spPr>
+          <a:xfrm>
+            <a:off x="640080" y="5760720"/>
+            <a:ext cx="10972800" cy="5029200"/>
+          </a:xfrm>
+          <a:prstGeom prst="rect">
+            <a:avLst/>
+          </a:prstGeom>
+          <a:noFill/>
+        </p:spPr>
+        <p:txBody>
+          <a:bodyPr wrap="square">
+            <a:spAutoFit/>
+          </a:bodyPr>
+          <a:lstStyle/>
+          <a:p>
+            <a:pPr>
+              <a:spcAft>
+                <a:spcPts val="600"/>
+              </a:spcAft>
+            </a:pPr>
+            <a:r>
+              <a:rPr sz="1400">
+                <a:solidFill>
+                  <a:srgbClr val="424242"/>
+                </a:solidFill>
+              </a:rPr>
+              <a:t>PPO dort kalite olcutunde de onde; ozellikle 6-oda basarisinda (0.96 vs 0.27).</a:t>
+            </a:r>
+          </a:p>
+          <a:p>
+            <a:pPr>
+              <a:spcAft>
+                <a:spcPts val="600"/>
+              </a:spcAft>
+            </a:pPr>
+            <a:r>
+              <a:rPr sz="1400">
+                <a:solidFill>
+                  <a:srgbClr val="424242"/>
+                </a:solidFill>
+              </a:rPr>
+              <a:t>Bedeli: PPO 1.5M adim, SAC 500k. SAC off-policy =&gt; replay buffer ile adim basina daha ornek-verimli.</a:t>
+            </a:r>
+          </a:p>
+          <a:p>
+            <a:pPr>
+              <a:spcAft>
+                <a:spcPts val="600"/>
+              </a:spcAft>
+            </a:pPr>
+            <a:r>
+              <a:rPr sz="1400">
+                <a:solidFill>
+                  <a:srgbClr val="424242"/>
+                </a:solidFill>
+              </a:rPr>
+              <a:t>Ders ayrimi: SAC az adimda hizli oturur, PPO daha cok adimla daha yuksek nihai basariya cikar.</a:t>
+            </a:r>
+          </a:p>
+        </p:txBody>
+      </p:sp>
+    </p:spTree>
+  </p:cSld>
+  <p:clrMapOvr>
+    <a:masterClrMapping/>
+  </p:clrMapOvr>
+</p:sld>
+</file>
+
+<file path=ppt/slides/slide13.xml><?xml version="1.0" encoding="utf-8"?>
+<p:sld xmlns:a="http://schemas.openxmlformats.org/drawingml/2006/main" xmlns:p="http://schemas.openxmlformats.org/presentationml/2006/main" xmlns:r="http://schemas.openxmlformats.org/officeDocument/2006/relationships">
+  <p:cSld>
+    <p:spTree>
+      <p:nvGrpSpPr>
+        <p:cNvPr id="1" name=""/>
+        <p:cNvGrpSpPr/>
+        <p:nvPr/>
+      </p:nvGrpSpPr>
+      <p:grpSpPr/>
+      <p:sp>
+        <p:nvSpPr>
+          <p:cNvPr id="2" name="TextBox 1"/>
+          <p:cNvSpPr txBox="1"/>
+          <p:nvPr/>
+        </p:nvSpPr>
+        <p:spPr>
+          <a:xfrm>
+            <a:off x="548640" y="274320"/>
+            <a:ext cx="11064240" cy="822960"/>
+          </a:xfrm>
+          <a:prstGeom prst="rect">
+            <a:avLst/>
+          </a:prstGeom>
+          <a:noFill/>
+        </p:spPr>
+        <p:txBody>
+          <a:bodyPr wrap="square">
+            <a:spAutoFit/>
+          </a:bodyPr>
+          <a:lstStyle/>
+          <a:p>
+            <a:r>
+              <a:rPr sz="3000" b="1">
+                <a:solidFill>
+                  <a:srgbClr val="1A237E"/>
+                </a:solidFill>
+              </a:rPr>
               <a:t>Savunma Ozeti (4 Kavram Alani)</a:t>
             </a:r>
           </a:p>
@@ -3645,7 +4228,7 @@
 </p:sld>
 </file>
 
-<file path=ppt/slides/slide13.xml><?xml version="1.0" encoding="utf-8"?>
+<file path=ppt/slides/slide14.xml><?xml version="1.0" encoding="utf-8"?>
 <p:sld xmlns:a="http://schemas.openxmlformats.org/drawingml/2006/main" xmlns:p="http://schemas.openxmlformats.org/presentationml/2006/main" xmlns:r="http://schemas.openxmlformats.org/officeDocument/2006/relationships">
   <p:cSld>
     <p:spTree>

</xml_diff>

<commit_message>
kiyas: yan-yana yaklasim (Akif'in yayinlanmis SAC grafikleri) + kendi SAC referanslari tamamen temizlendi
- C1-C5 overlaid kaldirildi; KIYAS_1-6 yan-yana figurler (make_comparison_figs.py)
- train_sac/runs_sac/sac_eval/loglar_sac kaldirildi; rapor/sunum/kiyas/kod/DEGISIKLIK temizlendi
- kiyas tablosu Akif'in (220202082) yayinlanmis sayilari (el-yazimi)

Co-Authored-By: Claude Opus 4.8 (1M context) <noreply@anthropic.com>
</commit_message>
<xml_diff>
--- a/deliverables/sunum/220202046_sunum.pptx
+++ b/deliverables/sunum/220202046_sunum.pptx
@@ -37,6 +37,7 @@
     <p:sldId id="285" r:id="rId36"/>
     <p:sldId id="286" r:id="rId37"/>
     <p:sldId id="287" r:id="rId38"/>
+    <p:sldId id="288" r:id="rId39"/>
   </p:sldIdLst>
   <p:sldSz cx="12191695" cy="6858000" type="screen4x3"/>
   <p:notesSz cx="6858000" cy="9144000"/>
@@ -6229,7 +6230,7 @@
                             <a:srgbClr val="FFFFFF"/>
                           </a:solidFill>
                         </a:rPr>
-                        <a:t>SAC (aynı ortam)</a:t>
+                        <a:t>SAC (M.A. Albayrak, 220202082)</a:t>
                       </a:r>
                     </a:p>
                   </a:txBody>
@@ -6354,7 +6355,7 @@
                     <a:p>
                       <a:r>
                         <a:rPr sz="1400" b="0"/>
-                        <a:t>Ort. eval getirisi</a:t>
+                        <a:t>Ort. getiri (5 tohum)</a:t>
                       </a:r>
                     </a:p>
                   </a:txBody>
@@ -6388,7 +6389,7 @@
                     <a:p>
                       <a:r>
                         <a:rPr sz="1400" b="0"/>
-                        <a:t>337.0</a:t>
+                        <a:t>314.6</a:t>
                       </a:r>
                     </a:p>
                   </a:txBody>
@@ -6407,7 +6408,60 @@
                     <a:p>
                       <a:r>
                         <a:rPr sz="1400" b="0"/>
-                        <a:t>Başarı oranı (6 oda)</a:t>
+                        <a:t>Ort. oda (/6)</a:t>
+                      </a:r>
+                    </a:p>
+                  </a:txBody>
+                  <a:tcPr>
+                    <a:solidFill>
+                      <a:srgbClr val="F2F4FB"/>
+                    </a:solidFill>
+                  </a:tcPr>
+                </a:tc>
+                <a:tc>
+                  <a:txBody>
+                    <a:bodyPr/>
+                    <a:lstStyle/>
+                    <a:p>
+                      <a:r>
+                        <a:rPr sz="1400" b="1"/>
+                        <a:t>5.80</a:t>
+                      </a:r>
+                    </a:p>
+                  </a:txBody>
+                  <a:tcPr>
+                    <a:solidFill>
+                      <a:srgbClr val="F2F4FB"/>
+                    </a:solidFill>
+                  </a:tcPr>
+                </a:tc>
+                <a:tc>
+                  <a:txBody>
+                    <a:bodyPr/>
+                    <a:lstStyle/>
+                    <a:p>
+                      <a:r>
+                        <a:rPr sz="1400" b="0"/>
+                        <a:t>4.83</a:t>
+                      </a:r>
+                    </a:p>
+                  </a:txBody>
+                  <a:tcPr>
+                    <a:solidFill>
+                      <a:srgbClr val="F2F4FB"/>
+                    </a:solidFill>
+                  </a:tcPr>
+                </a:tc>
+              </a:tr>
+              <a:tr h="522514">
+                <a:tc>
+                  <a:txBody>
+                    <a:bodyPr/>
+                    <a:lstStyle/>
+                    <a:p>
+                      <a:r>
+                        <a:rPr sz="1400" b="0"/>
+                        <a:t>Tam-keşif başarı oranı</a:t>
                       </a:r>
                     </a:p>
                   </a:txBody>
@@ -6452,7 +6506,7 @@
                   </a:tcPr>
                 </a:tc>
               </a:tr>
-              <a:tr h="522514">
+              <a:tr h="522516">
                 <a:tc>
                   <a:txBody>
                     <a:bodyPr/>
@@ -6460,7 +6514,7 @@
                     <a:p>
                       <a:r>
                         <a:rPr sz="1400" b="0"/>
-                        <a:t>Ort. kapsama %</a:t>
+                        <a:t>En iyi tohum getirisi</a:t>
                       </a:r>
                     </a:p>
                   </a:txBody>
@@ -6477,7 +6531,7 @@
                     <a:p>
                       <a:r>
                         <a:rPr sz="1400" b="1"/>
-                        <a:t>96.7</a:t>
+                        <a:t>474.6</a:t>
                       </a:r>
                     </a:p>
                   </a:txBody>
@@ -6494,60 +6548,7 @@
                     <a:p>
                       <a:r>
                         <a:rPr sz="1400" b="0"/>
-                        <a:t>92.8</a:t>
-                      </a:r>
-                    </a:p>
-                  </a:txBody>
-                  <a:tcPr>
-                    <a:solidFill>
-                      <a:srgbClr val="F2F4FB"/>
-                    </a:solidFill>
-                  </a:tcPr>
-                </a:tc>
-              </a:tr>
-              <a:tr h="522516">
-                <a:tc>
-                  <a:txBody>
-                    <a:bodyPr/>
-                    <a:lstStyle/>
-                    <a:p>
-                      <a:r>
-                        <a:rPr sz="1400" b="0"/>
-                        <a:t>Eval çarpışma oranı</a:t>
-                      </a:r>
-                    </a:p>
-                  </a:txBody>
-                  <a:tcPr>
-                    <a:solidFill>
-                      <a:srgbClr val="F2F4FB"/>
-                    </a:solidFill>
-                  </a:tcPr>
-                </a:tc>
-                <a:tc>
-                  <a:txBody>
-                    <a:bodyPr/>
-                    <a:lstStyle/>
-                    <a:p>
-                      <a:r>
-                        <a:rPr sz="1400" b="1"/>
-                        <a:t>0.04</a:t>
-                      </a:r>
-                    </a:p>
-                  </a:txBody>
-                  <a:tcPr>
-                    <a:solidFill>
-                      <a:srgbClr val="F2F4FB"/>
-                    </a:solidFill>
-                  </a:tcPr>
-                </a:tc>
-                <a:tc>
-                  <a:txBody>
-                    <a:bodyPr/>
-                    <a:lstStyle/>
-                    <a:p>
-                      <a:r>
-                        <a:rPr sz="1400" b="0"/>
-                        <a:t>0.15</a:t>
+                        <a:t>393.7</a:t>
                       </a:r>
                     </a:p>
                   </a:txBody>
@@ -6712,14 +6713,14 @@
                   <a:srgbClr val="FFFFFF"/>
                 </a:solidFill>
               </a:rPr>
-              <a:t>PPO vs SAC — Öğrenme Eğrisi</a:t>
+              <a:t>PPO ↔ SAC — Öğrenme Eğrisi</a:t>
             </a:r>
           </a:p>
         </p:txBody>
       </p:sp>
       <p:pic>
         <p:nvPicPr>
-          <p:cNvPr id="4" name="Picture 3" descr="C1_ogrenme_ppo_vs_sac.png"/>
+          <p:cNvPr id="4" name="Picture 3" descr="KIYAS_1_ogrenme.png"/>
           <p:cNvPicPr>
             <a:picLocks noChangeAspect="1"/>
           </p:cNvPicPr>
@@ -6733,8 +6734,8 @@
         </p:blipFill>
         <p:spPr>
           <a:xfrm>
-            <a:off x="320040" y="1143000"/>
-            <a:ext cx="8487536" cy="5029200"/>
+            <a:off x="548640" y="1188720"/>
+            <a:ext cx="11064240" cy="5918748"/>
           </a:xfrm>
           <a:prstGeom prst="rect">
             <a:avLst/>
@@ -6749,8 +6750,8 @@
         </p:nvSpPr>
         <p:spPr>
           <a:xfrm>
-            <a:off x="7955279" y="1188720"/>
-            <a:ext cx="4023360" cy="5212080"/>
+            <a:off x="548640" y="5806440"/>
+            <a:ext cx="11064240" cy="914400"/>
           </a:xfrm>
           <a:prstGeom prst="rect">
             <a:avLst/>
@@ -6764,72 +6765,12 @@
           <a:lstStyle/>
           <a:p>
             <a:r>
-              <a:rPr sz="1600" b="1">
-                <a:solidFill>
-                  <a:srgbClr val="1565C0"/>
-                </a:solidFill>
-              </a:rPr>
-              <a:t>Yorum</a:t>
-            </a:r>
-          </a:p>
-          <a:p>
-            <a:pPr>
-              <a:spcAft>
-                <a:spcPts val="500"/>
-              </a:spcAft>
-            </a:pPr>
-            <a:r>
-              <a:rPr sz="1250">
+              <a:rPr sz="1100">
                 <a:solidFill>
                   <a:srgbClr val="373737"/>
                 </a:solidFill>
               </a:rPr>
-              <a:t>Gözlem: SAC ilk birkaç yüz bin adımda PPO'dan hızlı yükselir; PPO daha çok adımla daha yüksek/kararlı platoya ulaşır.</a:t>
-            </a:r>
-          </a:p>
-          <a:p>
-            <a:pPr>
-              <a:spcAft>
-                <a:spcPts val="500"/>
-              </a:spcAft>
-            </a:pPr>
-            <a:r>
-              <a:rPr sz="1250">
-                <a:solidFill>
-                  <a:srgbClr val="373737"/>
-                </a:solidFill>
-              </a:rPr>
-              <a:t>Karşılaştırma: Tam ufukta PPO platosu daha yüksek.</a:t>
-            </a:r>
-          </a:p>
-          <a:p>
-            <a:pPr>
-              <a:spcAft>
-                <a:spcPts val="500"/>
-              </a:spcAft>
-            </a:pPr>
-            <a:r>
-              <a:rPr sz="1250">
-                <a:solidFill>
-                  <a:srgbClr val="373737"/>
-                </a:solidFill>
-              </a:rPr>
-              <a:t>Açıklama: SAC off-policy (replay buffer =&gt; adım başına verimli); PPO on-policy (rollout bir kez kullanılır).</a:t>
-            </a:r>
-          </a:p>
-          <a:p>
-            <a:pPr>
-              <a:spcAft>
-                <a:spcPts val="500"/>
-              </a:spcAft>
-            </a:pPr>
-            <a:r>
-              <a:rPr sz="1250">
-                <a:solidFill>
-                  <a:srgbClr val="373737"/>
-                </a:solidFill>
-              </a:rPr>
-              <a:t>Sonuç: Off-policy az adımda hızlı, on-policy çok adımla yüksek nihai başarı.</a:t>
+              <a:t>Sol PPO (bu çalışma), sağ SAC (M.A. Albayrak). PPO platosu (~480) SAC'ın (~390) üzerinde ve daha kararlı; SAC off-policy olduğu için daha az adımda yakınsar (örnek-verimli).</a:t>
             </a:r>
           </a:p>
         </p:txBody>
@@ -6931,14 +6872,14 @@
                   <a:srgbClr val="FFFFFF"/>
                 </a:solidFill>
               </a:rPr>
-              <a:t>PPO vs SAC — Örnek Verimliliği</a:t>
+              <a:t>PPO ↔ SAC — Tohum 123 Detay Paneli</a:t>
             </a:r>
           </a:p>
         </p:txBody>
       </p:sp>
       <p:pic>
         <p:nvPicPr>
-          <p:cNvPr id="4" name="Picture 3" descr="C2_ornek_verimliligi.png"/>
+          <p:cNvPr id="4" name="Picture 3" descr="KIYAS_3_perseed.png"/>
           <p:cNvPicPr>
             <a:picLocks noChangeAspect="1"/>
           </p:cNvPicPr>
@@ -6952,8 +6893,8 @@
         </p:blipFill>
         <p:spPr>
           <a:xfrm>
-            <a:off x="320040" y="1143000"/>
-            <a:ext cx="8487536" cy="5029200"/>
+            <a:off x="548640" y="1188720"/>
+            <a:ext cx="11064240" cy="5799575"/>
           </a:xfrm>
           <a:prstGeom prst="rect">
             <a:avLst/>
@@ -6968,8 +6909,8 @@
         </p:nvSpPr>
         <p:spPr>
           <a:xfrm>
-            <a:off x="7955279" y="1188720"/>
-            <a:ext cx="4023360" cy="5212080"/>
+            <a:off x="548640" y="5806440"/>
+            <a:ext cx="11064240" cy="914400"/>
           </a:xfrm>
           <a:prstGeom prst="rect">
             <a:avLst/>
@@ -6983,72 +6924,12 @@
           <a:lstStyle/>
           <a:p>
             <a:r>
-              <a:rPr sz="1600" b="1">
-                <a:solidFill>
-                  <a:srgbClr val="1565C0"/>
-                </a:solidFill>
-              </a:rPr>
-              <a:t>Yorum</a:t>
-            </a:r>
-          </a:p>
-          <a:p>
-            <a:pPr>
-              <a:spcAft>
-                <a:spcPts val="500"/>
-              </a:spcAft>
-            </a:pPr>
-            <a:r>
-              <a:rPr sz="1250">
+              <a:rPr sz="1100">
                 <a:solidFill>
                   <a:srgbClr val="373737"/>
                 </a:solidFill>
               </a:rPr>
-              <a:t>Gözlem: Aynı env-adım penceresinde SAC üstte başlar.</a:t>
-            </a:r>
-          </a:p>
-          <a:p>
-            <a:pPr>
-              <a:spcAft>
-                <a:spcPts val="500"/>
-              </a:spcAft>
-            </a:pPr>
-            <a:r>
-              <a:rPr sz="1250">
-                <a:solidFill>
-                  <a:srgbClr val="373737"/>
-                </a:solidFill>
-              </a:rPr>
-              <a:t>Karşılaştırma: SAC erken avantajlı; PPO sonradan yakalar/geçer.</a:t>
-            </a:r>
-          </a:p>
-          <a:p>
-            <a:pPr>
-              <a:spcAft>
-                <a:spcPts val="500"/>
-              </a:spcAft>
-            </a:pPr>
-            <a:r>
-              <a:rPr sz="1250">
-                <a:solidFill>
-                  <a:srgbClr val="373737"/>
-                </a:solidFill>
-              </a:rPr>
-              <a:t>Açıklama: Replay buffer her deneyimi defalarca kullandığından SAC aynı adımda daha çok öğrenir.</a:t>
-            </a:r>
-          </a:p>
-          <a:p>
-            <a:pPr>
-              <a:spcAft>
-                <a:spcPts val="500"/>
-              </a:spcAft>
-            </a:pPr>
-            <a:r>
-              <a:rPr sz="1250">
-                <a:solidFill>
-                  <a:srgbClr val="373737"/>
-                </a:solidFill>
-              </a:rPr>
-              <a:t>Sonuç: Örnek-bütçesi kısıtlı senaryolar için SAC, bütçe bolca ise PPO avantajlı.</a:t>
+              <a:t>Dört panelde de (getiri/eval/kapsama/oda) PPO eğrileri daha yüksek ve daha az dalgalı; ikisi de coverage'ı %90+ ve odayı 5-6'ya taşır. İki algoritma da görevi çözer, PPO daha yüksek tavanla.</a:t>
             </a:r>
           </a:p>
         </p:txBody>
@@ -7150,14 +7031,14 @@
                   <a:srgbClr val="FFFFFF"/>
                 </a:solidFill>
               </a:rPr>
-              <a:t>PPO vs SAC — Deterministik Eval</a:t>
+              <a:t>PPO ↔ SAC — Baseline (görev metrikleri)</a:t>
             </a:r>
           </a:p>
         </p:txBody>
       </p:sp>
       <p:pic>
         <p:nvPicPr>
-          <p:cNvPr id="4" name="Picture 3" descr="C3_eval_ppo_vs_sac.png"/>
+          <p:cNvPr id="4" name="Picture 3" descr="KIYAS_5_baseline.png"/>
           <p:cNvPicPr>
             <a:picLocks noChangeAspect="1"/>
           </p:cNvPicPr>
@@ -7171,8 +7052,8 @@
         </p:blipFill>
         <p:spPr>
           <a:xfrm>
-            <a:off x="320040" y="1143000"/>
-            <a:ext cx="8528838" cy="5029200"/>
+            <a:off x="548640" y="1188720"/>
+            <a:ext cx="11064240" cy="2665456"/>
           </a:xfrm>
           <a:prstGeom prst="rect">
             <a:avLst/>
@@ -7187,8 +7068,8 @@
         </p:nvSpPr>
         <p:spPr>
           <a:xfrm>
-            <a:off x="7955279" y="1188720"/>
-            <a:ext cx="4023360" cy="5212080"/>
+            <a:off x="548640" y="5806440"/>
+            <a:ext cx="11064240" cy="914400"/>
           </a:xfrm>
           <a:prstGeom prst="rect">
             <a:avLst/>
@@ -7202,72 +7083,12 @@
           <a:lstStyle/>
           <a:p>
             <a:r>
-              <a:rPr sz="1600" b="1">
-                <a:solidFill>
-                  <a:srgbClr val="1565C0"/>
-                </a:solidFill>
-              </a:rPr>
-              <a:t>Yorum</a:t>
-            </a:r>
-          </a:p>
-          <a:p>
-            <a:pPr>
-              <a:spcAft>
-                <a:spcPts val="500"/>
-              </a:spcAft>
-            </a:pPr>
-            <a:r>
-              <a:rPr sz="1250">
+              <a:rPr sz="1100">
                 <a:solidFill>
                   <a:srgbClr val="373737"/>
                 </a:solidFill>
               </a:rPr>
-              <a:t>Gözlem: Greedy eval eğrisinde PPO platosu SAC'ın üzerinde.</a:t>
-            </a:r>
-          </a:p>
-          <a:p>
-            <a:pPr>
-              <a:spcAft>
-                <a:spcPts val="500"/>
-              </a:spcAft>
-            </a:pPr>
-            <a:r>
-              <a:rPr sz="1250">
-                <a:solidFill>
-                  <a:srgbClr val="373737"/>
-                </a:solidFill>
-              </a:rPr>
-              <a:t>Karşılaştırma: İkisi de stokastik eğitimle tutarlı; fark nihai seviyede.</a:t>
-            </a:r>
-          </a:p>
-          <a:p>
-            <a:pPr>
-              <a:spcAft>
-                <a:spcPts val="500"/>
-              </a:spcAft>
-            </a:pPr>
-            <a:r>
-              <a:rPr sz="1250">
-                <a:solidFill>
-                  <a:srgbClr val="373737"/>
-                </a:solidFill>
-              </a:rPr>
-              <a:t>Açıklama: PPO'nun klips'i kararlı/yüksek-tavanlı politika öğrenir.</a:t>
-            </a:r>
-          </a:p>
-          <a:p>
-            <a:pPr>
-              <a:spcAft>
-                <a:spcPts val="500"/>
-              </a:spcAft>
-            </a:pPr>
-            <a:r>
-              <a:rPr sz="1250">
-                <a:solidFill>
-                  <a:srgbClr val="373737"/>
-                </a:solidFill>
-              </a:rPr>
-              <a:t>Sonuç: Bu ortamda PPO nihai görev başarısında önde.</a:t>
+              <a:t>Her ikisi de rastgele/sezgiseli geçer; tam-keşif başarısında PPO (~%96) SAC'ın (~%60 en iyi, %34 ort.) belirgin önünde.</a:t>
             </a:r>
           </a:p>
         </p:txBody>
@@ -7369,14 +7190,14 @@
                   <a:srgbClr val="FFFFFF"/>
                 </a:solidFill>
               </a:rPr>
-              <a:t>PPO vs SAC — Oda Keşif Süreci</a:t>
+              <a:t>PPO ↔ SAC — Hiperparametre Duyarlılığı</a:t>
             </a:r>
           </a:p>
         </p:txBody>
       </p:sp>
       <p:pic>
         <p:nvPicPr>
-          <p:cNvPr id="4" name="Picture 3" descr="C5_oda_ppo_vs_sac.png"/>
+          <p:cNvPr id="4" name="Picture 3" descr="KIYAS_4_hiperparametre.png"/>
           <p:cNvPicPr>
             <a:picLocks noChangeAspect="1"/>
           </p:cNvPicPr>
@@ -7390,8 +7211,8 @@
         </p:blipFill>
         <p:spPr>
           <a:xfrm>
-            <a:off x="320040" y="1143000"/>
-            <a:ext cx="8379958" cy="5029200"/>
+            <a:off x="548640" y="1188720"/>
+            <a:ext cx="11064240" cy="3236264"/>
           </a:xfrm>
           <a:prstGeom prst="rect">
             <a:avLst/>
@@ -7406,8 +7227,8 @@
         </p:nvSpPr>
         <p:spPr>
           <a:xfrm>
-            <a:off x="7955279" y="1188720"/>
-            <a:ext cx="4023360" cy="5212080"/>
+            <a:off x="548640" y="5806440"/>
+            <a:ext cx="11064240" cy="914400"/>
           </a:xfrm>
           <a:prstGeom prst="rect">
             <a:avLst/>
@@ -7421,72 +7242,12 @@
           <a:lstStyle/>
           <a:p>
             <a:r>
-              <a:rPr sz="1600" b="1">
-                <a:solidFill>
-                  <a:srgbClr val="1565C0"/>
-                </a:solidFill>
-              </a:rPr>
-              <a:t>Yorum</a:t>
-            </a:r>
-          </a:p>
-          <a:p>
-            <a:pPr>
-              <a:spcAft>
-                <a:spcPts val="500"/>
-              </a:spcAft>
-            </a:pPr>
-            <a:r>
-              <a:rPr sz="1250">
+              <a:rPr sz="1100">
                 <a:solidFill>
                   <a:srgbClr val="373737"/>
                 </a:solidFill>
               </a:rPr>
-              <a:t>Gözlem: PPO ortalama oda sayısında 6'ya daha çok yaklaşır.</a:t>
-            </a:r>
-          </a:p>
-          <a:p>
-            <a:pPr>
-              <a:spcAft>
-                <a:spcPts val="500"/>
-              </a:spcAft>
-            </a:pPr>
-            <a:r>
-              <a:rPr sz="1250">
-                <a:solidFill>
-                  <a:srgbClr val="373737"/>
-                </a:solidFill>
-              </a:rPr>
-              <a:t>Karşılaştırma: SAC hızlı başlar ama nihai oda kapsaması PPO'nun gerisinde.</a:t>
-            </a:r>
-          </a:p>
-          <a:p>
-            <a:pPr>
-              <a:spcAft>
-                <a:spcPts val="500"/>
-              </a:spcAft>
-            </a:pPr>
-            <a:r>
-              <a:rPr sz="1250">
-                <a:solidFill>
-                  <a:srgbClr val="373737"/>
-                </a:solidFill>
-              </a:rPr>
-              <a:t>Açıklama: PPO'nun yüksek-tavanlı politikası sistematik oda-oda keşfi daha iyi yapar.</a:t>
-            </a:r>
-          </a:p>
-          <a:p>
-            <a:pPr>
-              <a:spcAft>
-                <a:spcPts val="500"/>
-              </a:spcAft>
-            </a:pPr>
-            <a:r>
-              <a:rPr sz="1250">
-                <a:solidFill>
-                  <a:srgbClr val="373737"/>
-                </a:solidFill>
-              </a:rPr>
-              <a:t>Sonuç: Görev metriğinde (oda) PPO üstün.</a:t>
+              <a:t>İki algoritmada da orta hiperparametre değerleri en iyi (keşif-sömürü dengesi); sonuç ince ayara aşırı duyarlı değil.</a:t>
             </a:r>
           </a:p>
         </p:txBody>
@@ -7803,14 +7564,14 @@
                   <a:srgbClr val="FFFFFF"/>
                 </a:solidFill>
               </a:rPr>
-              <a:t>PPO vs SAC — Final Metrik Barları</a:t>
+              <a:t>PPO ↔ SAC — Loss Eğrileri</a:t>
             </a:r>
           </a:p>
         </p:txBody>
       </p:sp>
       <p:pic>
         <p:nvPicPr>
-          <p:cNvPr id="4" name="Picture 3" descr="C4_final_metrik_bar.png"/>
+          <p:cNvPr id="4" name="Picture 3" descr="KIYAS_2_loss.png"/>
           <p:cNvPicPr>
             <a:picLocks noChangeAspect="1"/>
           </p:cNvPicPr>
@@ -7825,7 +7586,7 @@
         <p:spPr>
           <a:xfrm>
             <a:off x="548640" y="1188720"/>
-            <a:ext cx="11064240" cy="2690856"/>
+            <a:ext cx="11064240" cy="5509830"/>
           </a:xfrm>
           <a:prstGeom prst="rect">
             <a:avLst/>
@@ -7860,7 +7621,7 @@
                   <a:srgbClr val="373737"/>
                 </a:solidFill>
               </a:rPr>
-              <a:t>Gözlem: Getiri, oda, kapsama, başarı PPO'da yüksek; çarpışma PPO'da düşük.  Karşılaştırma: Dört kalite ölçütünde PPO önde, güvenlikte (çarpışma) de daha iyi.  Açıklama: Aynı ortam/seed/protokolde fark yalnızca algoritmadan gelir.  Sonuç: Bu çok-odalı keşif görevinde PPO nihai başarı/güvenlikte üstün.</a:t>
+              <a:t>PPO'da klips güncellemeleri sıkı sınırlar (actor loss küçük/yatay); SAC'ta entropi+replay ile loss daha geniş salınır. İkisi de kararlı.</a:t>
             </a:r>
           </a:p>
         </p:txBody>
@@ -7957,26 +7718,50 @@
           <a:lstStyle/>
           <a:p>
             <a:r>
-              <a:rPr sz="2800" b="1">
+              <a:rPr sz="2300" b="1">
                 <a:solidFill>
                   <a:srgbClr val="FFFFFF"/>
                 </a:solidFill>
               </a:rPr>
-              <a:t>Savunma Özeti (4 Kavram Alanı)</a:t>
-            </a:r>
-          </a:p>
-        </p:txBody>
-      </p:sp>
-      <p:sp>
-        <p:nvSpPr>
-          <p:cNvPr id="4" name="TextBox 3"/>
+              <a:t>PPO ↔ SAC — γ × lr Araması</a:t>
+            </a:r>
+          </a:p>
+        </p:txBody>
+      </p:sp>
+      <p:pic>
+        <p:nvPicPr>
+          <p:cNvPr id="4" name="Picture 3" descr="KIYAS_6_heatmap.png"/>
+          <p:cNvPicPr>
+            <a:picLocks noChangeAspect="1"/>
+          </p:cNvPicPr>
+          <p:nvPr/>
+        </p:nvPicPr>
+        <p:blipFill>
+          <a:blip r:embed="rId2"/>
+          <a:stretch>
+            <a:fillRect/>
+          </a:stretch>
+        </p:blipFill>
+        <p:spPr>
+          <a:xfrm>
+            <a:off x="548640" y="1188720"/>
+            <a:ext cx="11064240" cy="4271988"/>
+          </a:xfrm>
+          <a:prstGeom prst="rect">
+            <a:avLst/>
+          </a:prstGeom>
+        </p:spPr>
+      </p:pic>
+      <p:sp>
+        <p:nvSpPr>
+          <p:cNvPr id="5" name="TextBox 4"/>
           <p:cNvSpPr txBox="1"/>
           <p:nvPr/>
         </p:nvSpPr>
         <p:spPr>
           <a:xfrm>
-            <a:off x="640080" y="1234440"/>
-            <a:ext cx="10972800" cy="5212080"/>
+            <a:off x="548640" y="5806440"/>
+            <a:ext cx="11064240" cy="914400"/>
           </a:xfrm>
           <a:prstGeom prst="rect">
             <a:avLst/>
@@ -7989,63 +7774,13 @@
           </a:bodyPr>
           <a:lstStyle/>
           <a:p>
-            <a:pPr>
-              <a:spcAft>
-                <a:spcPts val="700"/>
-              </a:spcAft>
-            </a:pPr>
-            <a:r>
-              <a:rPr sz="1600">
+            <a:r>
+              <a:rPr sz="1100">
                 <a:solidFill>
                   <a:srgbClr val="373737"/>
                 </a:solidFill>
               </a:rPr>
-              <a:t>Stokastik mi? EVET. Kanıt kod satırı: rüzgar (step), lidar (_compute_lidar), odom (_make_obs) gürültüsü =&gt; p(s'|s,a) dejenere değil.</a:t>
-            </a:r>
-          </a:p>
-          <a:p>
-            <a:pPr>
-              <a:spcAft>
-                <a:spcPts val="700"/>
-              </a:spcAft>
-            </a:pPr>
-            <a:r>
-              <a:rPr sz="1600">
-                <a:solidFill>
-                  <a:srgbClr val="373737"/>
-                </a:solidFill>
-              </a:rPr>
-              <a:t>On/Off-policy? ON-POLICY. Davranış = hedef politika; replay buffer yok; veri kullanılıp atılır.</a:t>
-            </a:r>
-          </a:p>
-          <a:p>
-            <a:pPr>
-              <a:spcAft>
-                <a:spcPts val="700"/>
-              </a:spcAft>
-            </a:pPr>
-            <a:r>
-              <a:rPr sz="1600">
-                <a:solidFill>
-                  <a:srgbClr val="373737"/>
-                </a:solidFill>
-              </a:rPr>
-              <a:t>Markov? Yaklaşık sağlanır: lidar + hız (önceki eylem) + adım-deterministik engeller; gürültü/sınırlı görüş ile yalnızca yaklaşık.</a:t>
-            </a:r>
-          </a:p>
-          <a:p>
-            <a:pPr>
-              <a:spcAft>
-                <a:spcPts val="700"/>
-              </a:spcAft>
-            </a:pPr>
-            <a:r>
-              <a:rPr sz="1600">
-                <a:solidFill>
-                  <a:srgbClr val="373737"/>
-                </a:solidFill>
-              </a:rPr>
-              <a:t>POMDP mi? EVET. Gerçek durum != gözlem: odom gürültüsü, görüş-dışı duvarlar, engelin gelecek konumu gözlemde yok.</a:t>
+              <a:t>Her ikisinde de en iyi bölge orta-yüksek γ + düşük-orta lr köşesi; ortamın paylaşılan yapısını (gecikmeli oda ödülü) yansıtır.</a:t>
             </a:r>
           </a:p>
         </p:txBody>
@@ -8147,7 +7882,7 @@
                   <a:srgbClr val="FFFFFF"/>
                 </a:solidFill>
               </a:rPr>
-              <a:t>Sonuç</a:t>
+              <a:t>Savunma Özeti (4 Kavram Alanı)</a:t>
             </a:r>
           </a:p>
         </p:txBody>
@@ -8180,12 +7915,12 @@
               </a:spcAft>
             </a:pPr>
             <a:r>
-              <a:rPr sz="1800">
+              <a:rPr sz="1600">
                 <a:solidFill>
                   <a:srgbClr val="373737"/>
                 </a:solidFill>
               </a:rPr>
-              <a:t>PPO, on-policy ve replay buffer'sız olmasına rağmen rastgele ve sezgisel taban politikalarını belirgin geçti.</a:t>
+              <a:t>Stokastik mi? EVET. Kanıt kod satırı: rüzgar (step), lidar (_compute_lidar), odom (_make_obs) gürültüsü =&gt; p(s'|s,a) dejenere değil.</a:t>
             </a:r>
           </a:p>
           <a:p>
@@ -8195,12 +7930,12 @@
               </a:spcAft>
             </a:pPr>
             <a:r>
-              <a:rPr sz="1800">
+              <a:rPr sz="1600">
                 <a:solidFill>
                   <a:srgbClr val="373737"/>
                 </a:solidFill>
               </a:rPr>
-              <a:t>5 hiperparametre (clip/ent/gamma/lr/vf) yeniden eğitilerek tarandı; seçilen taban değerler gürbüz orta nokta.</a:t>
+              <a:t>On/Off-policy? ON-POLICY. Davranış = hedef politika; replay buffer yok; veri kullanılıp atılır.</a:t>
             </a:r>
           </a:p>
           <a:p>
@@ -8210,12 +7945,197 @@
               </a:spcAft>
             </a:pPr>
             <a:r>
+              <a:rPr sz="1600">
+                <a:solidFill>
+                  <a:srgbClr val="373737"/>
+                </a:solidFill>
+              </a:rPr>
+              <a:t>Markov? Yaklaşık sağlanır: lidar + hız (önceki eylem) + adım-deterministik engeller; gürültü/sınırlı görüş ile yalnızca yaklaşık.</a:t>
+            </a:r>
+          </a:p>
+          <a:p>
+            <a:pPr>
+              <a:spcAft>
+                <a:spcPts val="700"/>
+              </a:spcAft>
+            </a:pPr>
+            <a:r>
+              <a:rPr sz="1600">
+                <a:solidFill>
+                  <a:srgbClr val="373737"/>
+                </a:solidFill>
+              </a:rPr>
+              <a:t>POMDP mi? EVET. Gerçek durum != gözlem: odom gürültüsü, görüş-dışı duvarlar, engelin gelecek konumu gözlemde yok.</a:t>
+            </a:r>
+          </a:p>
+        </p:txBody>
+      </p:sp>
+    </p:spTree>
+  </p:cSld>
+  <p:clrMapOvr>
+    <a:masterClrMapping/>
+  </p:clrMapOvr>
+</p:sld>
+</file>
+
+<file path=ppt/slides/slide33.xml><?xml version="1.0" encoding="utf-8"?>
+<p:sld xmlns:a="http://schemas.openxmlformats.org/drawingml/2006/main" xmlns:p="http://schemas.openxmlformats.org/presentationml/2006/main" xmlns:r="http://schemas.openxmlformats.org/officeDocument/2006/relationships">
+  <p:cSld>
+    <p:bg>
+      <p:bgPr>
+        <a:solidFill>
+          <a:srgbClr val="FFFFFF"/>
+        </a:solidFill>
+        <a:effectLst/>
+      </p:bgPr>
+    </p:bg>
+    <p:spTree>
+      <p:nvGrpSpPr>
+        <p:cNvPr id="1" name=""/>
+        <p:cNvGrpSpPr/>
+        <p:nvPr/>
+      </p:nvGrpSpPr>
+      <p:grpSpPr/>
+      <p:sp>
+        <p:nvSpPr>
+          <p:cNvPr id="2" name="Rectangle 1"/>
+          <p:cNvSpPr/>
+          <p:nvPr/>
+        </p:nvSpPr>
+        <p:spPr>
+          <a:xfrm>
+            <a:off x="0" y="0"/>
+            <a:ext cx="12191695" cy="960120"/>
+          </a:xfrm>
+          <a:prstGeom prst="rect">
+            <a:avLst/>
+          </a:prstGeom>
+          <a:solidFill>
+            <a:srgbClr val="1A237E"/>
+          </a:solidFill>
+          <a:ln>
+            <a:noFill/>
+          </a:ln>
+        </p:spPr>
+        <p:style>
+          <a:lnRef idx="1">
+            <a:schemeClr val="accent1"/>
+          </a:lnRef>
+          <a:fillRef idx="3">
+            <a:schemeClr val="accent1"/>
+          </a:fillRef>
+          <a:effectRef idx="2">
+            <a:schemeClr val="accent1"/>
+          </a:effectRef>
+          <a:fontRef idx="minor">
+            <a:schemeClr val="lt1"/>
+          </a:fontRef>
+        </p:style>
+        <p:txBody>
+          <a:bodyPr rtlCol="0" anchor="ctr"/>
+          <a:lstStyle/>
+          <a:p>
+            <a:pPr algn="ctr"/>
+          </a:p>
+        </p:txBody>
+      </p:sp>
+      <p:sp>
+        <p:nvSpPr>
+          <p:cNvPr id="3" name="TextBox 2"/>
+          <p:cNvSpPr txBox="1"/>
+          <p:nvPr/>
+        </p:nvSpPr>
+        <p:spPr>
+          <a:xfrm>
+            <a:off x="457200" y="164592"/>
+            <a:ext cx="11247120" cy="685800"/>
+          </a:xfrm>
+          <a:prstGeom prst="rect">
+            <a:avLst/>
+          </a:prstGeom>
+          <a:noFill/>
+        </p:spPr>
+        <p:txBody>
+          <a:bodyPr wrap="square">
+            <a:spAutoFit/>
+          </a:bodyPr>
+          <a:lstStyle/>
+          <a:p>
+            <a:r>
+              <a:rPr sz="2800" b="1">
+                <a:solidFill>
+                  <a:srgbClr val="FFFFFF"/>
+                </a:solidFill>
+              </a:rPr>
+              <a:t>Sonuç</a:t>
+            </a:r>
+          </a:p>
+        </p:txBody>
+      </p:sp>
+      <p:sp>
+        <p:nvSpPr>
+          <p:cNvPr id="4" name="TextBox 3"/>
+          <p:cNvSpPr txBox="1"/>
+          <p:nvPr/>
+        </p:nvSpPr>
+        <p:spPr>
+          <a:xfrm>
+            <a:off x="640080" y="1234440"/>
+            <a:ext cx="10972800" cy="5212080"/>
+          </a:xfrm>
+          <a:prstGeom prst="rect">
+            <a:avLst/>
+          </a:prstGeom>
+          <a:noFill/>
+        </p:spPr>
+        <p:txBody>
+          <a:bodyPr wrap="square">
+            <a:spAutoFit/>
+          </a:bodyPr>
+          <a:lstStyle/>
+          <a:p>
+            <a:pPr>
+              <a:spcAft>
+                <a:spcPts val="700"/>
+              </a:spcAft>
+            </a:pPr>
+            <a:r>
               <a:rPr sz="1800">
                 <a:solidFill>
                   <a:srgbClr val="373737"/>
                 </a:solidFill>
               </a:rPr>
-              <a:t>Aynı ortamda eğitilen SAC ile kıyas, on-policy/off-policy ayrımını gerçek eğrilerle gösterdi.</a:t>
+              <a:t>PPO, on-policy ve replay buffer'sız olmasına rağmen rastgele ve sezgisel taban politikalarını belirgin geçti.</a:t>
+            </a:r>
+          </a:p>
+          <a:p>
+            <a:pPr>
+              <a:spcAft>
+                <a:spcPts val="700"/>
+              </a:spcAft>
+            </a:pPr>
+            <a:r>
+              <a:rPr sz="1800">
+                <a:solidFill>
+                  <a:srgbClr val="373737"/>
+                </a:solidFill>
+              </a:rPr>
+              <a:t>5 hiperparametre (clip/ent/gamma/lr/vf) yeniden eğitilerek tarandı; seçilen taban değerler gürbüz orta nokta.</a:t>
+            </a:r>
+          </a:p>
+          <a:p>
+            <a:pPr>
+              <a:spcAft>
+                <a:spcPts val="700"/>
+              </a:spcAft>
+            </a:pPr>
+            <a:r>
+              <a:rPr sz="1800">
+                <a:solidFill>
+                  <a:srgbClr val="373737"/>
+                </a:solidFill>
+              </a:rPr>
+              <a:t>Akif'in yayınlanmış SAC grafikleriyle yan-yana kıyas, on-policy/off-policy ayrımını gösterdi.</a:t>
             </a:r>
           </a:p>
           <a:p>

</xml_diff>

<commit_message>
savunma: rapor+sunum detaylandirildi (4 alan, stokastiklik degerleri+kod satiri+ornek, her isterler.md sorusu gerekceli)
- rapor Bolum 9: 4 alt-bolum, sigma degerleri, p(s'|s,a) ornegi, top/Atari analojileri, belief state
- sunum: tek savunma slaydi -> 4 detayli slayt + Ortam slaytina stokastiklik degerleri
- DesignFolder/prompt.md ayni detayla guncellendi
</commit_message>
<xml_diff>
--- a/deliverables/sunum/220202046_sunum.pptx
+++ b/deliverables/sunum/220202046_sunum.pptx
@@ -38,6 +38,9 @@
     <p:sldId id="286" r:id="rId37"/>
     <p:sldId id="287" r:id="rId38"/>
     <p:sldId id="288" r:id="rId39"/>
+    <p:sldId id="289" r:id="rId40"/>
+    <p:sldId id="290" r:id="rId41"/>
+    <p:sldId id="291" r:id="rId42"/>
   </p:sldIdLst>
   <p:sldSz cx="12191695" cy="6858000" type="screen4x3"/>
   <p:notesSz cx="6858000" cy="9144000"/>
@@ -7882,7 +7885,7 @@
                   <a:srgbClr val="FFFFFF"/>
                 </a:solidFill>
               </a:rPr>
-              <a:t>Savunma Özeti (4 Kavram Alanı)</a:t>
+              <a:t>Savunma 1 — Deterministik mi, Stokastik mi?  →  STOKASTİK</a:t>
             </a:r>
           </a:p>
         </p:txBody>
@@ -7915,12 +7918,12 @@
               </a:spcAft>
             </a:pPr>
             <a:r>
-              <a:rPr sz="1600">
-                <a:solidFill>
-                  <a:srgbClr val="373737"/>
-                </a:solidFill>
-              </a:rPr>
-              <a:t>Stokastik mi? EVET. Kanıt kod satırı: rüzgar (step), lidar (_compute_lidar), odom (_make_obs) gürültüsü =&gt; p(s'|s,a) dejenere değil.</a:t>
+              <a:rPr sz="1400">
+                <a:solidFill>
+                  <a:srgbClr val="373737"/>
+                </a:solidFill>
+              </a:rPr>
+              <a:t>Tanım: ortam stokastik ⇔ p(s′|s,a) dejenere DEĞİL — aynı (s,a) farklı s′ üretebilir.</a:t>
             </a:r>
           </a:p>
           <a:p>
@@ -7930,12 +7933,72 @@
               </a:spcAft>
             </a:pPr>
             <a:r>
-              <a:rPr sz="1600">
-                <a:solidFill>
-                  <a:srgbClr val="373737"/>
-                </a:solidFill>
-              </a:rPr>
-              <a:t>On/Off-policy? ON-POLICY. Davranış = hedef politika; replay buffer yok; veri kullanılıp atılır.</a:t>
+              <a:rPr sz="1400">
+                <a:solidFill>
+                  <a:srgbClr val="373737"/>
+                </a:solidFill>
+              </a:rPr>
+              <a:t>Stokastikliği sağlayan değerler (kod satırı ile):</a:t>
+            </a:r>
+          </a:p>
+          <a:p>
+            <a:pPr lvl="1">
+              <a:spcAft>
+                <a:spcPts val="700"/>
+              </a:spcAft>
+            </a:pPr>
+            <a:r>
+              <a:rPr sz="1200">
+                <a:solidFill>
+                  <a:srgbClr val="373737"/>
+                </a:solidFill>
+              </a:rPr>
+              <a:t>• Rüzgar σ=0.015 → hız komutuna eklenir: vx,vy,ω += N(0,0.015)  [step(), satır 133-135] — GEÇİŞ gürültüsü.</a:t>
+            </a:r>
+          </a:p>
+          <a:p>
+            <a:pPr lvl="1">
+              <a:spcAft>
+                <a:spcPts val="700"/>
+              </a:spcAft>
+            </a:pPr>
+            <a:r>
+              <a:rPr sz="1200">
+                <a:solidFill>
+                  <a:srgbClr val="373737"/>
+                </a:solidFill>
+              </a:rPr>
+              <a:t>• Lidar σ=0.015 → her ışın mesafesine  [_compute_lidar, 319-320] — gözlem gürültüsü.</a:t>
+            </a:r>
+          </a:p>
+          <a:p>
+            <a:pPr lvl="1">
+              <a:spcAft>
+                <a:spcPts val="700"/>
+              </a:spcAft>
+            </a:pPr>
+            <a:r>
+              <a:rPr sz="1200">
+                <a:solidFill>
+                  <a:srgbClr val="373737"/>
+                </a:solidFill>
+              </a:rPr>
+              <a:t>• Odometri σ=0.004 → ölçülen poz/yaw'a  [_make_obs, 233-236] — gözlem gürültüsü.</a:t>
+            </a:r>
+          </a:p>
+          <a:p>
+            <a:pPr lvl="1">
+              <a:spcAft>
+                <a:spcPts val="700"/>
+              </a:spcAft>
+            </a:pPr>
+            <a:r>
+              <a:rPr sz="1200">
+                <a:solidFill>
+                  <a:srgbClr val="373737"/>
+                </a:solidFill>
+              </a:rPr>
+              <a:t>• 3 hareketli engel, sinüzoidal/zaman-değişken  [_moving_obstacles, 203-206].</a:t>
             </a:r>
           </a:p>
           <a:p>
@@ -7945,12 +8008,12 @@
               </a:spcAft>
             </a:pPr>
             <a:r>
-              <a:rPr sz="1600">
-                <a:solidFill>
-                  <a:srgbClr val="373737"/>
-                </a:solidFill>
-              </a:rPr>
-              <a:t>Markov? Yaklaşık sağlanır: lidar + hız (önceki eylem) + adım-deterministik engeller; gürültü/sınırlı görüş ile yalnızca yaklaşık.</a:t>
+              <a:rPr sz="1400">
+                <a:solidFill>
+                  <a:srgbClr val="373737"/>
+                </a:solidFill>
+              </a:rPr>
+              <a:t>Örnek: drone (5,5), eylem 'tam ileri'. Gürültüsüz s′=(5.144, 5.0); ama vx+=ε → her oynatımda farklı → s′ bir DAĞILIM (tek nokta değil).</a:t>
             </a:r>
           </a:p>
           <a:p>
@@ -7960,12 +8023,12 @@
               </a:spcAft>
             </a:pPr>
             <a:r>
-              <a:rPr sz="1600">
-                <a:solidFill>
-                  <a:srgbClr val="373737"/>
-                </a:solidFill>
-              </a:rPr>
-              <a:t>POMDP mi? EVET. Gerçek durum != gözlem: odom gürültüsü, görüş-dışı duvarlar, engelin gelecek konumu gözlemde yok.</a:t>
+              <a:rPr sz="1400">
+                <a:solidFill>
+                  <a:srgbClr val="373737"/>
+                </a:solidFill>
+              </a:rPr>
+              <a:t>Aynı tohum = sadece TEKRARLANABİLİRLİK (deterministik değil). Başlangıç rastgeleliği TEK BAŞINA stokastiklik değildir; stokastiklik geçiş+gözlem gürültüsünden gelir.</a:t>
             </a:r>
           </a:p>
         </p:txBody>
@@ -8067,6 +8130,606 @@
                   <a:srgbClr val="FFFFFF"/>
                 </a:solidFill>
               </a:rPr>
+              <a:t>Savunma 2 — On-policy mi, Off-policy mi?  →  ON-POLICY</a:t>
+            </a:r>
+          </a:p>
+        </p:txBody>
+      </p:sp>
+      <p:sp>
+        <p:nvSpPr>
+          <p:cNvPr id="4" name="TextBox 3"/>
+          <p:cNvSpPr txBox="1"/>
+          <p:nvPr/>
+        </p:nvSpPr>
+        <p:spPr>
+          <a:xfrm>
+            <a:off x="640080" y="1234440"/>
+            <a:ext cx="10972800" cy="5212080"/>
+          </a:xfrm>
+          <a:prstGeom prst="rect">
+            <a:avLst/>
+          </a:prstGeom>
+          <a:noFill/>
+        </p:spPr>
+        <p:txBody>
+          <a:bodyPr wrap="square">
+            <a:spAutoFit/>
+          </a:bodyPr>
+          <a:lstStyle/>
+          <a:p>
+            <a:pPr>
+              <a:spcAft>
+                <a:spcPts val="700"/>
+              </a:spcAft>
+            </a:pPr>
+            <a:r>
+              <a:rPr sz="1500">
+                <a:solidFill>
+                  <a:srgbClr val="373737"/>
+                </a:solidFill>
+              </a:rPr>
+              <a:t>Davranış politikası = hedef politika (aynı π_θ). Veri güncel π_θ ile toplanır, n_epochs sonra ATILIR; replay buffer YOK.</a:t>
+            </a:r>
+          </a:p>
+          <a:p>
+            <a:pPr>
+              <a:spcAft>
+                <a:spcPts val="700"/>
+              </a:spcAft>
+            </a:pPr>
+            <a:r>
+              <a:rPr sz="1500">
+                <a:solidFill>
+                  <a:srgbClr val="373737"/>
+                </a:solidFill>
+              </a:rPr>
+              <a:t>Bu on-policy'nin tanımı; SAC/DQN'in (replay buffer'lı off-policy) tersi.</a:t>
+            </a:r>
+          </a:p>
+          <a:p>
+            <a:pPr>
+              <a:spcAft>
+                <a:spcPts val="700"/>
+              </a:spcAft>
+            </a:pPr>
+            <a:r>
+              <a:rPr sz="1500">
+                <a:solidFill>
+                  <a:srgbClr val="373737"/>
+                </a:solidFill>
+              </a:rPr>
+              <a:t>Neden örnek-verimsiz? Her veri yalnız 1 kez kullanılır; politika değişince eski veri off-policy olup atılır → daha çok çevre etkileşimi (8 paralel ortam telafi).</a:t>
+            </a:r>
+          </a:p>
+          <a:p>
+            <a:pPr>
+              <a:spcAft>
+                <a:spcPts val="700"/>
+              </a:spcAft>
+            </a:pPr>
+            <a:r>
+              <a:rPr sz="1500">
+                <a:solidFill>
+                  <a:srgbClr val="373737"/>
+                </a:solidFill>
+              </a:rPr>
+              <a:t>SARSA vs Q-Learning (tek satır fark): SARSA hedefi Q(s′,a′) (davranıştan a′, on-policy); Q-Learning max_a Q(s′,a) (greedy hedef, off-policy).</a:t>
+            </a:r>
+          </a:p>
+          <a:p>
+            <a:pPr>
+              <a:spcAft>
+                <a:spcPts val="700"/>
+              </a:spcAft>
+            </a:pPr>
+            <a:r>
+              <a:rPr sz="1500">
+                <a:solidFill>
+                  <a:srgbClr val="373737"/>
+                </a:solidFill>
+              </a:rPr>
+              <a:t>Off-policy avantajı: replay ile veriyi tekrar kullanır (örnek-verimli); riski: eski veri güncel politikadan sapabilir (kararlılık).</a:t>
+            </a:r>
+          </a:p>
+        </p:txBody>
+      </p:sp>
+    </p:spTree>
+  </p:cSld>
+  <p:clrMapOvr>
+    <a:masterClrMapping/>
+  </p:clrMapOvr>
+</p:sld>
+</file>
+
+<file path=ppt/slides/slide34.xml><?xml version="1.0" encoding="utf-8"?>
+<p:sld xmlns:a="http://schemas.openxmlformats.org/drawingml/2006/main" xmlns:p="http://schemas.openxmlformats.org/presentationml/2006/main" xmlns:r="http://schemas.openxmlformats.org/officeDocument/2006/relationships">
+  <p:cSld>
+    <p:bg>
+      <p:bgPr>
+        <a:solidFill>
+          <a:srgbClr val="FFFFFF"/>
+        </a:solidFill>
+        <a:effectLst/>
+      </p:bgPr>
+    </p:bg>
+    <p:spTree>
+      <p:nvGrpSpPr>
+        <p:cNvPr id="1" name=""/>
+        <p:cNvGrpSpPr/>
+        <p:nvPr/>
+      </p:nvGrpSpPr>
+      <p:grpSpPr/>
+      <p:sp>
+        <p:nvSpPr>
+          <p:cNvPr id="2" name="Rectangle 1"/>
+          <p:cNvSpPr/>
+          <p:nvPr/>
+        </p:nvSpPr>
+        <p:spPr>
+          <a:xfrm>
+            <a:off x="0" y="0"/>
+            <a:ext cx="12191695" cy="960120"/>
+          </a:xfrm>
+          <a:prstGeom prst="rect">
+            <a:avLst/>
+          </a:prstGeom>
+          <a:solidFill>
+            <a:srgbClr val="1A237E"/>
+          </a:solidFill>
+          <a:ln>
+            <a:noFill/>
+          </a:ln>
+        </p:spPr>
+        <p:style>
+          <a:lnRef idx="1">
+            <a:schemeClr val="accent1"/>
+          </a:lnRef>
+          <a:fillRef idx="3">
+            <a:schemeClr val="accent1"/>
+          </a:fillRef>
+          <a:effectRef idx="2">
+            <a:schemeClr val="accent1"/>
+          </a:effectRef>
+          <a:fontRef idx="minor">
+            <a:schemeClr val="lt1"/>
+          </a:fontRef>
+        </p:style>
+        <p:txBody>
+          <a:bodyPr rtlCol="0" anchor="ctr"/>
+          <a:lstStyle/>
+          <a:p>
+            <a:pPr algn="ctr"/>
+          </a:p>
+        </p:txBody>
+      </p:sp>
+      <p:sp>
+        <p:nvSpPr>
+          <p:cNvPr id="3" name="TextBox 2"/>
+          <p:cNvSpPr txBox="1"/>
+          <p:nvPr/>
+        </p:nvSpPr>
+        <p:spPr>
+          <a:xfrm>
+            <a:off x="457200" y="164592"/>
+            <a:ext cx="11247120" cy="685800"/>
+          </a:xfrm>
+          <a:prstGeom prst="rect">
+            <a:avLst/>
+          </a:prstGeom>
+          <a:noFill/>
+        </p:spPr>
+        <p:txBody>
+          <a:bodyPr wrap="square">
+            <a:spAutoFit/>
+          </a:bodyPr>
+          <a:lstStyle/>
+          <a:p>
+            <a:r>
+              <a:rPr sz="2800" b="1">
+                <a:solidFill>
+                  <a:srgbClr val="FFFFFF"/>
+                </a:solidFill>
+              </a:rPr>
+              <a:t>Savunma 3 — Markov Özelliği?  →  YAKLAŞIK Markov</a:t>
+            </a:r>
+          </a:p>
+        </p:txBody>
+      </p:sp>
+      <p:sp>
+        <p:nvSpPr>
+          <p:cNvPr id="4" name="TextBox 3"/>
+          <p:cNvSpPr txBox="1"/>
+          <p:nvPr/>
+        </p:nvSpPr>
+        <p:spPr>
+          <a:xfrm>
+            <a:off x="640080" y="1234440"/>
+            <a:ext cx="10972800" cy="5212080"/>
+          </a:xfrm>
+          <a:prstGeom prst="rect">
+            <a:avLst/>
+          </a:prstGeom>
+          <a:noFill/>
+        </p:spPr>
+        <p:txBody>
+          <a:bodyPr wrap="square">
+            <a:spAutoFit/>
+          </a:bodyPr>
+          <a:lstStyle/>
+          <a:p>
+            <a:pPr>
+              <a:spcAft>
+                <a:spcPts val="700"/>
+              </a:spcAft>
+            </a:pPr>
+            <a:r>
+              <a:rPr sz="1500">
+                <a:solidFill>
+                  <a:srgbClr val="373737"/>
+                </a:solidFill>
+              </a:rPr>
+              <a:t>Tanım: P(s_{t+1}|s_t,a_t) = P(s_{t+1}|s_t,a_t,...,s_0) — gelecek yalnız şimdiki duruma bağlı, geçmişe değil.</a:t>
+            </a:r>
+          </a:p>
+          <a:p>
+            <a:pPr>
+              <a:spcAft>
+                <a:spcPts val="700"/>
+              </a:spcAft>
+            </a:pPr>
+            <a:r>
+              <a:rPr sz="1500">
+                <a:solidFill>
+                  <a:srgbClr val="373737"/>
+                </a:solidFill>
+              </a:rPr>
+              <a:t>Durumda önceki eylem(3) VAR → HIZ/momentum bilgisini taşır (top örneği: yalnız konum Markov değil, konum+hız Markov).</a:t>
+            </a:r>
+          </a:p>
+          <a:p>
+            <a:pPr>
+              <a:spcAft>
+                <a:spcPts val="700"/>
+              </a:spcAft>
+            </a:pPr>
+            <a:r>
+              <a:rPr sz="1500">
+                <a:solidFill>
+                  <a:srgbClr val="373737"/>
+                </a:solidFill>
+              </a:rPr>
+              <a:t>Eksik bilgi: hareketli engel konumu t'nin fonksiyonu (sin(2πt/T)) ama durum t'yi/engel fazını AÇIKÇA içermez → engelin gelecek yeri tek gözlemden tam belirlenemez → YAKLAŞIK Markov.</a:t>
+            </a:r>
+          </a:p>
+          <a:p>
+            <a:pPr>
+              <a:spcAft>
+                <a:spcPts val="700"/>
+              </a:spcAft>
+            </a:pPr>
+            <a:r>
+              <a:rPr sz="1500">
+                <a:solidFill>
+                  <a:srgbClr val="373737"/>
+                </a:solidFill>
+              </a:rPr>
+              <a:t>Atari: tek kare hızı vermez (Markov değil), DeepMind 4 kare istifledi; bizdeki karşılık önceki eylemi durumda tutmak.</a:t>
+            </a:r>
+          </a:p>
+          <a:p>
+            <a:pPr>
+              <a:spcAft>
+                <a:spcPts val="700"/>
+              </a:spcAft>
+            </a:pPr>
+            <a:r>
+              <a:rPr sz="1500">
+                <a:solidFill>
+                  <a:srgbClr val="373737"/>
+                </a:solidFill>
+              </a:rPr>
+              <a:t>Markov değilse 2 çözüm: (i) durumu zenginleştir (hız/faz ekle — biz önceki eylemi ekledik), (ii) bellek (RNN/LSTM, kare istifleme).</a:t>
+            </a:r>
+          </a:p>
+        </p:txBody>
+      </p:sp>
+    </p:spTree>
+  </p:cSld>
+  <p:clrMapOvr>
+    <a:masterClrMapping/>
+  </p:clrMapOvr>
+</p:sld>
+</file>
+
+<file path=ppt/slides/slide35.xml><?xml version="1.0" encoding="utf-8"?>
+<p:sld xmlns:a="http://schemas.openxmlformats.org/drawingml/2006/main" xmlns:p="http://schemas.openxmlformats.org/presentationml/2006/main" xmlns:r="http://schemas.openxmlformats.org/officeDocument/2006/relationships">
+  <p:cSld>
+    <p:bg>
+      <p:bgPr>
+        <a:solidFill>
+          <a:srgbClr val="FFFFFF"/>
+        </a:solidFill>
+        <a:effectLst/>
+      </p:bgPr>
+    </p:bg>
+    <p:spTree>
+      <p:nvGrpSpPr>
+        <p:cNvPr id="1" name=""/>
+        <p:cNvGrpSpPr/>
+        <p:nvPr/>
+      </p:nvGrpSpPr>
+      <p:grpSpPr/>
+      <p:sp>
+        <p:nvSpPr>
+          <p:cNvPr id="2" name="Rectangle 1"/>
+          <p:cNvSpPr/>
+          <p:nvPr/>
+        </p:nvSpPr>
+        <p:spPr>
+          <a:xfrm>
+            <a:off x="0" y="0"/>
+            <a:ext cx="12191695" cy="960120"/>
+          </a:xfrm>
+          <a:prstGeom prst="rect">
+            <a:avLst/>
+          </a:prstGeom>
+          <a:solidFill>
+            <a:srgbClr val="1A237E"/>
+          </a:solidFill>
+          <a:ln>
+            <a:noFill/>
+          </a:ln>
+        </p:spPr>
+        <p:style>
+          <a:lnRef idx="1">
+            <a:schemeClr val="accent1"/>
+          </a:lnRef>
+          <a:fillRef idx="3">
+            <a:schemeClr val="accent1"/>
+          </a:fillRef>
+          <a:effectRef idx="2">
+            <a:schemeClr val="accent1"/>
+          </a:effectRef>
+          <a:fontRef idx="minor">
+            <a:schemeClr val="lt1"/>
+          </a:fontRef>
+        </p:style>
+        <p:txBody>
+          <a:bodyPr rtlCol="0" anchor="ctr"/>
+          <a:lstStyle/>
+          <a:p>
+            <a:pPr algn="ctr"/>
+          </a:p>
+        </p:txBody>
+      </p:sp>
+      <p:sp>
+        <p:nvSpPr>
+          <p:cNvPr id="3" name="TextBox 2"/>
+          <p:cNvSpPr txBox="1"/>
+          <p:nvPr/>
+        </p:nvSpPr>
+        <p:spPr>
+          <a:xfrm>
+            <a:off x="457200" y="164592"/>
+            <a:ext cx="11247120" cy="685800"/>
+          </a:xfrm>
+          <a:prstGeom prst="rect">
+            <a:avLst/>
+          </a:prstGeom>
+          <a:noFill/>
+        </p:spPr>
+        <p:txBody>
+          <a:bodyPr wrap="square">
+            <a:spAutoFit/>
+          </a:bodyPr>
+          <a:lstStyle/>
+          <a:p>
+            <a:r>
+              <a:rPr sz="2800" b="1">
+                <a:solidFill>
+                  <a:srgbClr val="FFFFFF"/>
+                </a:solidFill>
+              </a:rPr>
+              <a:t>Savunma 4 — Kısmi Gözlemlenebilir mi?  →  EVET (POMDP)</a:t>
+            </a:r>
+          </a:p>
+        </p:txBody>
+      </p:sp>
+      <p:sp>
+        <p:nvSpPr>
+          <p:cNvPr id="4" name="TextBox 3"/>
+          <p:cNvSpPr txBox="1"/>
+          <p:nvPr/>
+        </p:nvSpPr>
+        <p:spPr>
+          <a:xfrm>
+            <a:off x="640080" y="1234440"/>
+            <a:ext cx="10972800" cy="5212080"/>
+          </a:xfrm>
+          <a:prstGeom prst="rect">
+            <a:avLst/>
+          </a:prstGeom>
+          <a:noFill/>
+        </p:spPr>
+        <p:txBody>
+          <a:bodyPr wrap="square">
+            <a:spAutoFit/>
+          </a:bodyPr>
+          <a:lstStyle/>
+          <a:p>
+            <a:pPr>
+              <a:spcAft>
+                <a:spcPts val="700"/>
+              </a:spcAft>
+            </a:pPr>
+            <a:r>
+              <a:rPr sz="1400">
+                <a:solidFill>
+                  <a:srgbClr val="373737"/>
+                </a:solidFill>
+              </a:rPr>
+              <a:t>Gerçek durum s: drone'un GERÇEK konum/yaw'ı, TÜM engellerin gerçek konumu, haritanın tam geometrisi.</a:t>
+            </a:r>
+          </a:p>
+          <a:p>
+            <a:pPr>
+              <a:spcAft>
+                <a:spcPts val="700"/>
+              </a:spcAft>
+            </a:pPr>
+            <a:r>
+              <a:rPr sz="1400">
+                <a:solidFill>
+                  <a:srgbClr val="373737"/>
+                </a:solidFill>
+              </a:rPr>
+              <a:t>Gözlem o: GÜRÜLTÜLÜ lidar (yalnız görüş hattı) + GÜRÜLTÜLÜ odometri poz/yaw + keşif istatistikleri.</a:t>
+            </a:r>
+          </a:p>
+          <a:p>
+            <a:pPr>
+              <a:spcAft>
+                <a:spcPts val="700"/>
+              </a:spcAft>
+            </a:pPr>
+            <a:r>
+              <a:rPr sz="1400">
+                <a:solidFill>
+                  <a:srgbClr val="373737"/>
+                </a:solidFill>
+              </a:rPr>
+              <a:t>Aradaki boşluk (eksik bilgi): (i) odom gürültüsü → ajan gerçek konumu TAM bilmez; (ii) lidar duvar ARKASINI görmez; (iii) engelin GELECEK konumu gözlemde yok.</a:t>
+            </a:r>
+          </a:p>
+          <a:p>
+            <a:pPr>
+              <a:spcAft>
+                <a:spcPts val="700"/>
+              </a:spcAft>
+            </a:pPr>
+            <a:r>
+              <a:rPr sz="1400">
+                <a:solidFill>
+                  <a:srgbClr val="373737"/>
+                </a:solidFill>
+              </a:rPr>
+              <a:t>Gözlem gürültüsü tek başına değil; asıl POMDP sınırlı görüşten (duvar arkası) gelir. Vanilla DQN yetersiz → bellek (RNN) veya gözlem istifleme gerekir.</a:t>
+            </a:r>
+          </a:p>
+          <a:p>
+            <a:pPr>
+              <a:spcAft>
+                <a:spcPts val="700"/>
+              </a:spcAft>
+            </a:pPr>
+            <a:r>
+              <a:rPr sz="1400">
+                <a:solidFill>
+                  <a:srgbClr val="373737"/>
+                </a:solidFill>
+              </a:rPr>
+              <a:t>Belief state: gerçek durum üzerindeki olasılık dağılımı (inanç); gözlemlerle Bayes ile güncellenir, POMDP'de optimal politika belief üzerinde tanımlıdır. Biz önceki eylem + politika bağlamıyla KISMEN telafi ederiz.</a:t>
+            </a:r>
+          </a:p>
+        </p:txBody>
+      </p:sp>
+    </p:spTree>
+  </p:cSld>
+  <p:clrMapOvr>
+    <a:masterClrMapping/>
+  </p:clrMapOvr>
+</p:sld>
+</file>
+
+<file path=ppt/slides/slide36.xml><?xml version="1.0" encoding="utf-8"?>
+<p:sld xmlns:a="http://schemas.openxmlformats.org/drawingml/2006/main" xmlns:p="http://schemas.openxmlformats.org/presentationml/2006/main" xmlns:r="http://schemas.openxmlformats.org/officeDocument/2006/relationships">
+  <p:cSld>
+    <p:bg>
+      <p:bgPr>
+        <a:solidFill>
+          <a:srgbClr val="FFFFFF"/>
+        </a:solidFill>
+        <a:effectLst/>
+      </p:bgPr>
+    </p:bg>
+    <p:spTree>
+      <p:nvGrpSpPr>
+        <p:cNvPr id="1" name=""/>
+        <p:cNvGrpSpPr/>
+        <p:nvPr/>
+      </p:nvGrpSpPr>
+      <p:grpSpPr/>
+      <p:sp>
+        <p:nvSpPr>
+          <p:cNvPr id="2" name="Rectangle 1"/>
+          <p:cNvSpPr/>
+          <p:nvPr/>
+        </p:nvSpPr>
+        <p:spPr>
+          <a:xfrm>
+            <a:off x="0" y="0"/>
+            <a:ext cx="12191695" cy="960120"/>
+          </a:xfrm>
+          <a:prstGeom prst="rect">
+            <a:avLst/>
+          </a:prstGeom>
+          <a:solidFill>
+            <a:srgbClr val="1A237E"/>
+          </a:solidFill>
+          <a:ln>
+            <a:noFill/>
+          </a:ln>
+        </p:spPr>
+        <p:style>
+          <a:lnRef idx="1">
+            <a:schemeClr val="accent1"/>
+          </a:lnRef>
+          <a:fillRef idx="3">
+            <a:schemeClr val="accent1"/>
+          </a:fillRef>
+          <a:effectRef idx="2">
+            <a:schemeClr val="accent1"/>
+          </a:effectRef>
+          <a:fontRef idx="minor">
+            <a:schemeClr val="lt1"/>
+          </a:fontRef>
+        </p:style>
+        <p:txBody>
+          <a:bodyPr rtlCol="0" anchor="ctr"/>
+          <a:lstStyle/>
+          <a:p>
+            <a:pPr algn="ctr"/>
+          </a:p>
+        </p:txBody>
+      </p:sp>
+      <p:sp>
+        <p:nvSpPr>
+          <p:cNvPr id="3" name="TextBox 2"/>
+          <p:cNvSpPr txBox="1"/>
+          <p:nvPr/>
+        </p:nvSpPr>
+        <p:spPr>
+          <a:xfrm>
+            <a:off x="457200" y="164592"/>
+            <a:ext cx="11247120" cy="685800"/>
+          </a:xfrm>
+          <a:prstGeom prst="rect">
+            <a:avLst/>
+          </a:prstGeom>
+          <a:noFill/>
+        </p:spPr>
+        <p:txBody>
+          <a:bodyPr wrap="square">
+            <a:spAutoFit/>
+          </a:bodyPr>
+          <a:lstStyle/>
+          <a:p>
+            <a:r>
+              <a:rPr sz="2800" b="1">
+                <a:solidFill>
+                  <a:srgbClr val="FFFFFF"/>
+                </a:solidFill>
+              </a:rPr>
               <a:t>Sonuç</a:t>
             </a:r>
           </a:p>
@@ -8285,7 +8948,7 @@
               </a:spcAft>
             </a:pPr>
             <a:r>
-              <a:rPr sz="1700">
+              <a:rPr sz="1600">
                 <a:solidFill>
                   <a:srgbClr val="373737"/>
                 </a:solidFill>
@@ -8300,7 +8963,7 @@
               </a:spcAft>
             </a:pPr>
             <a:r>
-              <a:rPr sz="1700">
+              <a:rPr sz="1600">
                 <a:solidFill>
                   <a:srgbClr val="373737"/>
                 </a:solidFill>
@@ -8315,7 +8978,7 @@
               </a:spcAft>
             </a:pPr>
             <a:r>
-              <a:rPr sz="1700">
+              <a:rPr sz="1600">
                 <a:solidFill>
                   <a:srgbClr val="373737"/>
                 </a:solidFill>
@@ -8330,7 +8993,7 @@
               </a:spcAft>
             </a:pPr>
             <a:r>
-              <a:rPr sz="1700">
+              <a:rPr sz="1600">
                 <a:solidFill>
                   <a:srgbClr val="373737"/>
                 </a:solidFill>
@@ -8345,7 +9008,7 @@
               </a:spcAft>
             </a:pPr>
             <a:r>
-              <a:rPr sz="1700">
+              <a:rPr sz="1600">
                 <a:solidFill>
                   <a:srgbClr val="373737"/>
                 </a:solidFill>
@@ -8360,7 +9023,22 @@
               </a:spcAft>
             </a:pPr>
             <a:r>
-              <a:rPr sz="1700">
+              <a:rPr sz="1600">
+                <a:solidFill>
+                  <a:srgbClr val="373737"/>
+                </a:solidFill>
+              </a:rPr>
+              <a:t>STOKASTİK: rüzgar σ=0.015 (geçiş, satır 133-135) + lidar σ=0.015 + odometri σ=0.004 (gözlem) + 3 hareketli engel → p(s′|s,a) dejenere değil.</a:t>
+            </a:r>
+          </a:p>
+          <a:p>
+            <a:pPr>
+              <a:spcAft>
+                <a:spcPts val="700"/>
+              </a:spcAft>
+            </a:pPr>
+            <a:r>
+              <a:rPr sz="1600">
                 <a:solidFill>
                   <a:srgbClr val="373737"/>
                 </a:solidFill>

</xml_diff>